<commit_message>
Switch experiments to cahousing, fix classifier evaluation
- experiments on cahousing (SA = ocean_proximity): TDG vs TDG + distinct
  l = 2, 3 and entropy l = 2 for k = 2 ... 100, reject / retry / repair
  comparison, recursive (c, l)
- new privacy metric: share of records with the majority SA value of their EC
- classifier evaluation: numbers with minus sign or decimal point became 0,
  rows were matched with labels by position instead of ID, '*' now uses
  the mean of the attribute
- report, slides and README updated
</commit_message>
<xml_diff>
--- a/report/SPAI_Exercise1_2_TopDown_l-diversity_slides.pptx
+++ b/report/SPAI_Exercise1_2_TopDown_l-diversity_slides.pptx
@@ -512,7 +512,7 @@
           <a:lstStyle/>
           <a:p>
             <a:r>
-              <a:t>Short intro: who we are, we did task 1.2 with Top-Down Greedy.</a:t>
+              <a:t>Short intro: who we are, we did task 1.2 with Top-Down Greedy on cahousing.</a:t>
             </a:r>
           </a:p>
         </p:txBody>
@@ -582,7 +582,7 @@
           <a:lstStyle/>
           <a:p>
             <a:r>
-              <a:t>Main message: l-diversity on top of TDG is cheap if you repair splits. Limitations are honest: one dataset, greedy repair, distinct l-diversity does not stop similarity attacks.</a:t>
+              <a:t>Main messages: it works, repair is the best strategy, but on cahousing distinct l-diversity alone is weak and strong l-diversity destroys the prediction of the same column.</a:t>
             </a:r>
           </a:p>
         </p:txBody>
@@ -652,7 +652,7 @@
           <a:lstStyle/>
           <a:p>
             <a:r>
-              <a:t>Example from the Italia dataset, plain TDG with k = 2. The table is 2-anonymous, but if I know my neighbour is 45 and from Veneto, I know she has heart disease. On Adult the same happens with occupation, and it does not completely go away with larger k.</a:t>
+              <a:t>Example from cahousing, original TDG with k = 10. The table is 10-anonymous, but if I know where a district is and roughly its income and house value, I know its ocean proximity for sure. The reason is that ocean proximity basically follows from longitude and latitude.</a:t>
             </a:r>
           </a:p>
         </p:txBody>
@@ -862,7 +862,7 @@
           <a:lstStyle/>
           <a:p>
             <a:r>
-              <a:t>We removed occupation from the QIs for both methods, otherwise the comparison would not be fair. Three experiments: vary l, vary k, and an ablation without the repair step.</a:t>
+              <a:t>cahousing is the dataset from the toolbox. ocean_proximity has only three values and is also the class the toolbox predicts, so l can only be 2 or 3. We also compare three ways of handling bad splits.</a:t>
             </a:r>
           </a:p>
         </p:txBody>
@@ -932,7 +932,7 @@
           <a:lstStyle/>
           <a:p>
             <a:r>
-              <a:t>Left: homogeneous ECs, middle: ECs with fewer than 3 occupations. The original TDG only becomes 3-diverse at k = 50, with NCP 0.25. Our method is 3-diverse at every k, with NCP 0.092 at k = 10.</a:t>
+              <a:t>Left and middle: the original TDG has a lot of homogeneous ECs, ours has none. Right: how often you are right if you guess the most frequent value of the EC. Distinct l = 2 still 87% at k = 10, because the ECs are very skewed, e.g. 393 vs. 2 districts. Only entropy l brings it close to the 44% you get without any QI.</a:t>
             </a:r>
           </a:p>
         </p:txBody>
@@ -1002,7 +1002,7 @@
           <a:lstStyle/>
           <a:p>
             <a:r>
-              <a:t>Dotted line is original TDG. Up to l = 5 the extra loss is very small, because occupation is quite balanced. Entropy is stricter: entropy l = 6 gives NCP 0.27. Runtime was in the same range for both, but our laptop measurements were too noisy for a real comparison.</a:t>
+              <a:t>Distinct l = 2 doubles the NCP at k = 2, but the gap closes with larger k. And compared at the same NCP it is better than just raising k: TDG at k = 20 has a similar NCP and still 7,255 districts in homogeneous ECs.</a:t>
             </a:r>
           </a:p>
         </p:txBody>
@@ -1072,7 +1072,7 @@
           <a:lstStyle/>
           <a:p>
             <a:r>
-              <a:t>This was the most interesting part for us. If you just reject a split that is not l-diverse, the recursion stops very early near the root, because TDG ignores the SA. The NCP is about 5 times higher.</a:t>
+              <a:t>Retry was our first idea: try up to 10 new random splits. It helps a bit, but a new random split has the same problem because the SA is ignored. The repair moves a few records with the missing values and gives the lowest NCP in all four settings.</a:t>
             </a:r>
           </a:p>
         </p:txBody>
@@ -1142,7 +1142,7 @@
           <a:lstStyle/>
           <a:p>
             <a:r>
-              <a:t>Grey line is the original data, dotted line the original TDG. All differences are around 0.01, which is noise level. Occupation is not a feature, the repair only touches a few records per EC.</a:t>
+              <a:t>Dashed line is the original data. ocean_proximity is the SA and the class at the same time, so l-diversity mixes classes inside every EC. l = 2 costs little, l = 3 and entropy cost a lot. KNN is weak even on the original data because the toolbox does not scale its features. We also found two bugs in the toolbox evaluation on cahousing (decimal numbers became 0, rows matched by position).</a:t>
             </a:r>
           </a:p>
         </p:txBody>
@@ -4618,7 +4618,7 @@
                   <a:srgbClr val="595959"/>
                 </a:solidFill>
               </a:rPr>
-              <a:t>•  k = 10, l = 3 is almost free (NCP +0.001, same F1)</a:t>
+              <a:t>•  repairing splits gives the lowest NCP</a:t>
             </a:r>
           </a:p>
           <a:p>
@@ -4633,7 +4633,7 @@
                   <a:srgbClr val="595959"/>
                 </a:solidFill>
               </a:rPr>
-              <a:t>•  raising k instead would need k = 50</a:t>
+              <a:t>•  better than raising k at the same information loss</a:t>
             </a:r>
           </a:p>
           <a:p>
@@ -4648,7 +4648,22 @@
                   <a:srgbClr val="595959"/>
                 </a:solidFill>
               </a:rPr>
-              <a:t>•  repairing splits is the key, rejecting them costs ~5x NCP</a:t>
+              <a:t>•  distinct l = 2 only removes certainty, majority guess still mostly right</a:t>
+            </a:r>
+          </a:p>
+          <a:p>
+            <a:pPr>
+              <a:spcAft>
+                <a:spcPts val="900"/>
+              </a:spcAft>
+            </a:pPr>
+            <a:r>
+              <a:rPr sz="1700">
+                <a:solidFill>
+                  <a:srgbClr val="595959"/>
+                </a:solidFill>
+              </a:rPr>
+              <a:t>•  entropy l protects, but costs a lot of utility</a:t>
             </a:r>
           </a:p>
         </p:txBody>
@@ -4724,7 +4739,7 @@
                   <a:srgbClr val="595959"/>
                 </a:solidFill>
               </a:rPr>
-              <a:t>•  one dataset, occupation is fairly balanced</a:t>
+              <a:t>•  only 3 SA values, SA = target</a:t>
             </a:r>
           </a:p>
           <a:p>
@@ -4754,7 +4769,7 @@
                   <a:srgbClr val="595959"/>
                 </a:solidFill>
               </a:rPr>
-              <a:t>•  distinct l does not stop skewness / similarity attacks -&gt; t-closeness</a:t>
+              <a:t>•  skewness / similarity attacks -&gt; t-closeness</a:t>
             </a:r>
           </a:p>
           <a:p>
@@ -4963,7 +4978,7 @@
                   <a:srgbClr val="1F3A5F"/>
                 </a:solidFill>
               </a:rPr>
-              <a:t>k-anonymity alone still leaks the disease</a:t>
+              <a:t>k-anonymity alone still leaks ocean proximity</a:t>
             </a:r>
           </a:p>
         </p:txBody>
@@ -5088,7 +5103,7 @@
         <p:spPr>
           <a:xfrm>
             <a:off x="548640" y="1325880"/>
-            <a:ext cx="5486400" cy="365760"/>
+            <a:ext cx="6400800" cy="365760"/>
           </a:xfrm>
           <a:prstGeom prst="rect">
             <a:avLst/>
@@ -5112,7 +5127,7 @@
                   <a:srgbClr val="1F3A5F"/>
                 </a:solidFill>
               </a:rPr>
-              <a:t>Italia, original TDG, k = 2 (excerpt)</a:t>
+              <a:t>cahousing, original TDG, k = 10 (largest homogeneous ECs)</a:t>
             </a:r>
           </a:p>
         </p:txBody>
@@ -5127,7 +5142,7 @@
         </p:nvGraphicFramePr>
         <p:xfrm>
           <a:off x="548640" y="1737360"/>
-          <a:ext cx="6035040" cy="2011680"/>
+          <a:ext cx="6400800" cy="2011680"/>
         </p:xfrm>
         <a:graphic>
           <a:graphicData uri="http://schemas.openxmlformats.org/drawingml/2006/table">
@@ -5136,10 +5151,12 @@
                 <a:tableStyleId>{5C22544A-7EE6-4342-B048-85BDC9FD1C3A}</a:tableStyleId>
               </a:tblPr>
               <a:tblGrid>
+                <a:gridCol w="914400"/>
                 <a:gridCol w="822960"/>
-                <a:gridCol w="1097280"/>
-                <a:gridCol w="822960"/>
-                <a:gridCol w="3291840"/>
+                <a:gridCol w="1005840"/>
+                <a:gridCol w="1463040"/>
+                <a:gridCol w="548640"/>
+                <a:gridCol w="1645920"/>
               </a:tblGrid>
               <a:tr h="402336">
                 <a:tc>
@@ -5148,12 +5165,12 @@
                     <a:lstStyle/>
                     <a:p>
                       <a:r>
-                        <a:rPr sz="1300" b="1">
+                        <a:rPr sz="1200" b="1">
                           <a:solidFill>
                             <a:srgbClr val="FFFFFF"/>
                           </a:solidFill>
                         </a:rPr>
-                        <a:t>age</a:t>
+                        <a:t>longitude</a:t>
                       </a:r>
                     </a:p>
                   </a:txBody>
@@ -5169,12 +5186,12 @@
                     <a:lstStyle/>
                     <a:p>
                       <a:r>
-                        <a:rPr sz="1300" b="1">
+                        <a:rPr sz="1200" b="1">
                           <a:solidFill>
                             <a:srgbClr val="FFFFFF"/>
                           </a:solidFill>
                         </a:rPr>
-                        <a:t>region</a:t>
+                        <a:t>latitude</a:t>
                       </a:r>
                     </a:p>
                   </a:txBody>
@@ -5190,12 +5207,12 @@
                     <a:lstStyle/>
                     <a:p>
                       <a:r>
-                        <a:rPr sz="1300" b="1">
+                        <a:rPr sz="1200" b="1">
                           <a:solidFill>
                             <a:srgbClr val="FFFFFF"/>
                           </a:solidFill>
                         </a:rPr>
-                        <a:t>zip</a:t>
+                        <a:t>income</a:t>
                       </a:r>
                     </a:p>
                   </a:txBody>
@@ -5211,12 +5228,54 @@
                     <a:lstStyle/>
                     <a:p>
                       <a:r>
-                        <a:rPr sz="1300" b="1">
+                        <a:rPr sz="1200" b="1">
                           <a:solidFill>
                             <a:srgbClr val="FFFFFF"/>
                           </a:solidFill>
                         </a:rPr>
-                        <a:t>disease</a:t>
+                        <a:t>house value</a:t>
+                      </a:r>
+                    </a:p>
+                  </a:txBody>
+                  <a:tcPr>
+                    <a:solidFill>
+                      <a:srgbClr val="1F3A5F"/>
+                    </a:solidFill>
+                  </a:tcPr>
+                </a:tc>
+                <a:tc>
+                  <a:txBody>
+                    <a:bodyPr/>
+                    <a:lstStyle/>
+                    <a:p>
+                      <a:r>
+                        <a:rPr sz="1200" b="1">
+                          <a:solidFill>
+                            <a:srgbClr val="FFFFFF"/>
+                          </a:solidFill>
+                        </a:rPr>
+                        <a:t>size</a:t>
+                      </a:r>
+                    </a:p>
+                  </a:txBody>
+                  <a:tcPr>
+                    <a:solidFill>
+                      <a:srgbClr val="1F3A5F"/>
+                    </a:solidFill>
+                  </a:tcPr>
+                </a:tc>
+                <a:tc>
+                  <a:txBody>
+                    <a:bodyPr/>
+                    <a:lstStyle/>
+                    <a:p>
+                      <a:r>
+                        <a:rPr sz="1200" b="1">
+                          <a:solidFill>
+                            <a:srgbClr val="FFFFFF"/>
+                          </a:solidFill>
+                        </a:rPr>
+                        <a:t>ocean_proximity</a:t>
                       </a:r>
                     </a:p>
                   </a:txBody>
@@ -5234,12 +5293,12 @@
                     <a:lstStyle/>
                     <a:p>
                       <a:r>
-                        <a:rPr sz="1300" b="0">
+                        <a:rPr sz="1200" b="0">
                           <a:solidFill>
                             <a:srgbClr val="595959"/>
                           </a:solidFill>
                         </a:rPr>
-                        <a:t>40~50</a:t>
+                        <a:t>-119</a:t>
                       </a:r>
                     </a:p>
                   </a:txBody>
@@ -5255,12 +5314,12 @@
                     <a:lstStyle/>
                     <a:p>
                       <a:r>
-                        <a:rPr sz="1300" b="0">
+                        <a:rPr sz="1200" b="0">
                           <a:solidFill>
                             <a:srgbClr val="595959"/>
                           </a:solidFill>
                         </a:rPr>
-                        <a:t>Veneto</a:t>
+                        <a:t>36</a:t>
                       </a:r>
                     </a:p>
                   </a:txBody>
@@ -5276,12 +5335,12 @@
                     <a:lstStyle/>
                     <a:p>
                       <a:r>
-                        <a:rPr sz="1300" b="0">
+                        <a:rPr sz="1200" b="0">
                           <a:solidFill>
                             <a:srgbClr val="595959"/>
                           </a:solidFill>
                         </a:rPr>
-                        <a:t>*****</a:t>
+                        <a:t>0 ~ 3.53</a:t>
                       </a:r>
                     </a:p>
                   </a:txBody>
@@ -5297,12 +5356,54 @@
                     <a:lstStyle/>
                     <a:p>
                       <a:r>
-                        <a:rPr sz="1300" b="0">
+                        <a:rPr sz="1200" b="0">
                           <a:solidFill>
                             <a:srgbClr val="595959"/>
                           </a:solidFill>
                         </a:rPr>
-                        <a:t>Heart disease, Heart disease</a:t>
+                        <a:t>14,000 ~ 74,999</a:t>
+                      </a:r>
+                    </a:p>
+                  </a:txBody>
+                  <a:tcPr>
+                    <a:solidFill>
+                      <a:srgbClr val="FBE3D0"/>
+                    </a:solidFill>
+                  </a:tcPr>
+                </a:tc>
+                <a:tc>
+                  <a:txBody>
+                    <a:bodyPr/>
+                    <a:lstStyle/>
+                    <a:p>
+                      <a:r>
+                        <a:rPr sz="1200" b="0">
+                          <a:solidFill>
+                            <a:srgbClr val="595959"/>
+                          </a:solidFill>
+                        </a:rPr>
+                        <a:t>74</a:t>
+                      </a:r>
+                    </a:p>
+                  </a:txBody>
+                  <a:tcPr>
+                    <a:solidFill>
+                      <a:srgbClr val="FBE3D0"/>
+                    </a:solidFill>
+                  </a:tcPr>
+                </a:tc>
+                <a:tc>
+                  <a:txBody>
+                    <a:bodyPr/>
+                    <a:lstStyle/>
+                    <a:p>
+                      <a:r>
+                        <a:rPr sz="1200" b="0">
+                          <a:solidFill>
+                            <a:srgbClr val="595959"/>
+                          </a:solidFill>
+                        </a:rPr>
+                        <a:t>2 (all 74)</a:t>
                       </a:r>
                     </a:p>
                   </a:txBody>
@@ -5320,12 +5421,12 @@
                     <a:lstStyle/>
                     <a:p>
                       <a:r>
-                        <a:rPr sz="1300" b="0">
+                        <a:rPr sz="1200" b="0">
                           <a:solidFill>
                             <a:srgbClr val="595959"/>
                           </a:solidFill>
                         </a:rPr>
-                        <a:t>50~100</a:t>
+                        <a:t>-121</a:t>
                       </a:r>
                     </a:p>
                   </a:txBody>
@@ -5341,12 +5442,12 @@
                     <a:lstStyle/>
                     <a:p>
                       <a:r>
-                        <a:rPr sz="1300" b="0">
+                        <a:rPr sz="1200" b="0">
                           <a:solidFill>
                             <a:srgbClr val="595959"/>
                           </a:solidFill>
                         </a:rPr>
-                        <a:t>Piemonte</a:t>
+                        <a:t>38</a:t>
                       </a:r>
                     </a:p>
                   </a:txBody>
@@ -5362,12 +5463,12 @@
                     <a:lstStyle/>
                     <a:p>
                       <a:r>
-                        <a:rPr sz="1300" b="0">
+                        <a:rPr sz="1200" b="0">
                           <a:solidFill>
                             <a:srgbClr val="595959"/>
                           </a:solidFill>
                         </a:rPr>
-                        <a:t>*****</a:t>
+                        <a:t>0 ~ 3.53</a:t>
                       </a:r>
                     </a:p>
                   </a:txBody>
@@ -5383,12 +5484,54 @@
                     <a:lstStyle/>
                     <a:p>
                       <a:r>
-                        <a:rPr sz="1300" b="0">
+                        <a:rPr sz="1200" b="0">
                           <a:solidFill>
                             <a:srgbClr val="595959"/>
                           </a:solidFill>
                         </a:rPr>
-                        <a:t>AIDS, AIDS</a:t>
+                        <a:t>75,000 ~ 135,999</a:t>
+                      </a:r>
+                    </a:p>
+                  </a:txBody>
+                  <a:tcPr>
+                    <a:solidFill>
+                      <a:srgbClr val="FBE3D0"/>
+                    </a:solidFill>
+                  </a:tcPr>
+                </a:tc>
+                <a:tc>
+                  <a:txBody>
+                    <a:bodyPr/>
+                    <a:lstStyle/>
+                    <a:p>
+                      <a:r>
+                        <a:rPr sz="1200" b="0">
+                          <a:solidFill>
+                            <a:srgbClr val="595959"/>
+                          </a:solidFill>
+                        </a:rPr>
+                        <a:t>66</a:t>
+                      </a:r>
+                    </a:p>
+                  </a:txBody>
+                  <a:tcPr>
+                    <a:solidFill>
+                      <a:srgbClr val="FBE3D0"/>
+                    </a:solidFill>
+                  </a:tcPr>
+                </a:tc>
+                <a:tc>
+                  <a:txBody>
+                    <a:bodyPr/>
+                    <a:lstStyle/>
+                    <a:p>
+                      <a:r>
+                        <a:rPr sz="1200" b="0">
+                          <a:solidFill>
+                            <a:srgbClr val="595959"/>
+                          </a:solidFill>
+                        </a:rPr>
+                        <a:t>2 (all 66)</a:t>
                       </a:r>
                     </a:p>
                   </a:txBody>
@@ -5406,12 +5549,12 @@
                     <a:lstStyle/>
                     <a:p>
                       <a:r>
-                        <a:rPr sz="1300" b="0">
+                        <a:rPr sz="1200" b="0">
                           <a:solidFill>
                             <a:srgbClr val="595959"/>
                           </a:solidFill>
                         </a:rPr>
-                        <a:t>30~40</a:t>
+                        <a:t>-119</a:t>
                       </a:r>
                     </a:p>
                   </a:txBody>
@@ -5427,12 +5570,12 @@
                     <a:lstStyle/>
                     <a:p>
                       <a:r>
-                        <a:rPr sz="1300" b="0">
+                        <a:rPr sz="1200" b="0">
                           <a:solidFill>
                             <a:srgbClr val="595959"/>
                           </a:solidFill>
                         </a:rPr>
-                        <a:t>Italy</a:t>
+                        <a:t>36</a:t>
                       </a:r>
                     </a:p>
                   </a:txBody>
@@ -5448,12 +5591,12 @@
                     <a:lstStyle/>
                     <a:p>
                       <a:r>
-                        <a:rPr sz="1300" b="0">
+                        <a:rPr sz="1200" b="0">
                           <a:solidFill>
                             <a:srgbClr val="595959"/>
                           </a:solidFill>
                         </a:rPr>
-                        <a:t>*****</a:t>
+                        <a:t>0 ~ 3.53</a:t>
                       </a:r>
                     </a:p>
                   </a:txBody>
@@ -5469,12 +5612,54 @@
                     <a:lstStyle/>
                     <a:p>
                       <a:r>
-                        <a:rPr sz="1300" b="0">
+                        <a:rPr sz="1200" b="0">
                           <a:solidFill>
                             <a:srgbClr val="595959"/>
                           </a:solidFill>
                         </a:rPr>
-                        <a:t>Anorexia, Anorexia</a:t>
+                        <a:t>14,000 ~ 74,999</a:t>
+                      </a:r>
+                    </a:p>
+                  </a:txBody>
+                  <a:tcPr>
+                    <a:solidFill>
+                      <a:srgbClr val="FBE3D0"/>
+                    </a:solidFill>
+                  </a:tcPr>
+                </a:tc>
+                <a:tc>
+                  <a:txBody>
+                    <a:bodyPr/>
+                    <a:lstStyle/>
+                    <a:p>
+                      <a:r>
+                        <a:rPr sz="1200" b="0">
+                          <a:solidFill>
+                            <a:srgbClr val="595959"/>
+                          </a:solidFill>
+                        </a:rPr>
+                        <a:t>64</a:t>
+                      </a:r>
+                    </a:p>
+                  </a:txBody>
+                  <a:tcPr>
+                    <a:solidFill>
+                      <a:srgbClr val="FBE3D0"/>
+                    </a:solidFill>
+                  </a:tcPr>
+                </a:tc>
+                <a:tc>
+                  <a:txBody>
+                    <a:bodyPr/>
+                    <a:lstStyle/>
+                    <a:p>
+                      <a:r>
+                        <a:rPr sz="1200" b="0">
+                          <a:solidFill>
+                            <a:srgbClr val="595959"/>
+                          </a:solidFill>
+                        </a:rPr>
+                        <a:t>2 (all 64)</a:t>
                       </a:r>
                     </a:p>
                   </a:txBody>
@@ -5492,18 +5677,18 @@
                     <a:lstStyle/>
                     <a:p>
                       <a:r>
-                        <a:rPr sz="1300" b="0">
+                        <a:rPr sz="1200" b="0">
                           <a:solidFill>
                             <a:srgbClr val="595959"/>
                           </a:solidFill>
                         </a:rPr>
-                        <a:t>10~20</a:t>
+                        <a:t>-118</a:t>
                       </a:r>
                     </a:p>
                   </a:txBody>
                   <a:tcPr>
                     <a:solidFill>
-                      <a:srgbClr val="FFFFFF"/>
+                      <a:srgbClr val="FBE3D0"/>
                     </a:solidFill>
                   </a:tcPr>
                 </a:tc>
@@ -5513,18 +5698,18 @@
                     <a:lstStyle/>
                     <a:p>
                       <a:r>
-                        <a:rPr sz="1300" b="0">
+                        <a:rPr sz="1200" b="0">
                           <a:solidFill>
                             <a:srgbClr val="595959"/>
                           </a:solidFill>
                         </a:rPr>
-                        <a:t>Italy</a:t>
+                        <a:t>33.8</a:t>
                       </a:r>
                     </a:p>
                   </a:txBody>
                   <a:tcPr>
                     <a:solidFill>
-                      <a:srgbClr val="FFFFFF"/>
+                      <a:srgbClr val="FBE3D0"/>
                     </a:solidFill>
                   </a:tcPr>
                 </a:tc>
@@ -5534,18 +5719,18 @@
                     <a:lstStyle/>
                     <a:p>
                       <a:r>
-                        <a:rPr sz="1300" b="0">
+                        <a:rPr sz="1200" b="0">
                           <a:solidFill>
                             <a:srgbClr val="595959"/>
                           </a:solidFill>
                         </a:rPr>
-                        <a:t>*****</a:t>
+                        <a:t>3.53 ~ 7.07</a:t>
                       </a:r>
                     </a:p>
                   </a:txBody>
                   <a:tcPr>
                     <a:solidFill>
-                      <a:srgbClr val="FFFFFF"/>
+                      <a:srgbClr val="FBE3D0"/>
                     </a:solidFill>
                   </a:tcPr>
                 </a:tc>
@@ -5555,18 +5740,60 @@
                     <a:lstStyle/>
                     <a:p>
                       <a:r>
-                        <a:rPr sz="1300" b="0">
+                        <a:rPr sz="1200" b="0">
                           <a:solidFill>
                             <a:srgbClr val="595959"/>
                           </a:solidFill>
                         </a:rPr>
-                        <a:t>Cancer, Autism, Heart d., Anorexia, ...</a:t>
+                        <a:t>197,000 ~ 257,999</a:t>
                       </a:r>
                     </a:p>
                   </a:txBody>
                   <a:tcPr>
                     <a:solidFill>
-                      <a:srgbClr val="FFFFFF"/>
+                      <a:srgbClr val="FBE3D0"/>
+                    </a:solidFill>
+                  </a:tcPr>
+                </a:tc>
+                <a:tc>
+                  <a:txBody>
+                    <a:bodyPr/>
+                    <a:lstStyle/>
+                    <a:p>
+                      <a:r>
+                        <a:rPr sz="1200" b="0">
+                          <a:solidFill>
+                            <a:srgbClr val="595959"/>
+                          </a:solidFill>
+                        </a:rPr>
+                        <a:t>50</a:t>
+                      </a:r>
+                    </a:p>
+                  </a:txBody>
+                  <a:tcPr>
+                    <a:solidFill>
+                      <a:srgbClr val="FBE3D0"/>
+                    </a:solidFill>
+                  </a:tcPr>
+                </a:tc>
+                <a:tc>
+                  <a:txBody>
+                    <a:bodyPr/>
+                    <a:lstStyle/>
+                    <a:p>
+                      <a:r>
+                        <a:rPr sz="1200" b="0">
+                          <a:solidFill>
+                            <a:srgbClr val="595959"/>
+                          </a:solidFill>
+                        </a:rPr>
+                        <a:t>1 (all 50)</a:t>
+                      </a:r>
+                    </a:p>
+                  </a:txBody>
+                  <a:tcPr>
+                    <a:solidFill>
+                      <a:srgbClr val="FBE3D0"/>
                     </a:solidFill>
                   </a:tcPr>
                 </a:tc>
@@ -5584,7 +5811,7 @@
         <p:spPr>
           <a:xfrm>
             <a:off x="548640" y="3886200"/>
-            <a:ext cx="6035040" cy="731520"/>
+            <a:ext cx="6400800" cy="731520"/>
           </a:xfrm>
           <a:prstGeom prst="rect">
             <a:avLst/>
@@ -5608,7 +5835,7 @@
                   <a:srgbClr val="595959"/>
                 </a:solidFill>
               </a:rPr>
-              <a:t>Orange rows: everyone in the class has the same disease (homogeneity attack).</a:t>
+              <a:t>Rows 1 and 3 differ in housing age. Everyone in the class has the same value (homogeneity attack). Age column left out.</a:t>
             </a:r>
           </a:p>
         </p:txBody>
@@ -5621,8 +5848,8 @@
         </p:nvSpPr>
         <p:spPr>
           <a:xfrm>
-            <a:off x="7132320" y="1325880"/>
-            <a:ext cx="4572000" cy="365760"/>
+            <a:off x="7498079" y="1325880"/>
+            <a:ext cx="4206240" cy="365760"/>
           </a:xfrm>
           <a:prstGeom prst="rect">
             <a:avLst/>
@@ -5646,7 +5873,7 @@
                   <a:srgbClr val="1F3A5F"/>
                 </a:solidFill>
               </a:rPr>
-              <a:t>Adult, SA = occupation, original TDG</a:t>
+              <a:t>Original TDG on cahousing</a:t>
             </a:r>
           </a:p>
         </p:txBody>
@@ -5659,8 +5886,8 @@
         </p:nvSpPr>
         <p:spPr>
           <a:xfrm>
-            <a:off x="7132320" y="1783080"/>
-            <a:ext cx="4480560" cy="1188720"/>
+            <a:off x="7498079" y="1783080"/>
+            <a:ext cx="4114800" cy="1188720"/>
           </a:xfrm>
           <a:prstGeom prst="rect">
             <a:avLst/>
@@ -5703,8 +5930,8 @@
         </p:nvSpPr>
         <p:spPr>
           <a:xfrm>
-            <a:off x="7315200" y="1892807"/>
-            <a:ext cx="1737360" cy="914400"/>
+            <a:off x="7680960" y="1892807"/>
+            <a:ext cx="1463040" cy="914400"/>
           </a:xfrm>
           <a:prstGeom prst="rect">
             <a:avLst/>
@@ -5728,7 +5955,7 @@
                   <a:srgbClr val="E07A1F"/>
                 </a:solidFill>
               </a:rPr>
-              <a:t>1,046</a:t>
+              <a:t>85%</a:t>
             </a:r>
           </a:p>
         </p:txBody>
@@ -5741,8 +5968,8 @@
         </p:nvSpPr>
         <p:spPr>
           <a:xfrm>
-            <a:off x="9052560" y="1892807"/>
-            <a:ext cx="2468880" cy="1005840"/>
+            <a:off x="9235440" y="1892807"/>
+            <a:ext cx="2286000" cy="1005840"/>
           </a:xfrm>
           <a:prstGeom prst="rect">
             <a:avLst/>
@@ -5766,7 +5993,7 @@
                   <a:srgbClr val="595959"/>
                 </a:solidFill>
               </a:rPr>
-              <a:t>ECs with only one occupation at k = 2 (2,404 people)</a:t>
+              <a:t>of districts in homogeneous ECs at k = 2</a:t>
             </a:r>
           </a:p>
         </p:txBody>
@@ -5779,8 +6006,8 @@
         </p:nvSpPr>
         <p:spPr>
           <a:xfrm>
-            <a:off x="7132320" y="3154680"/>
-            <a:ext cx="4480560" cy="1188720"/>
+            <a:off x="7498079" y="3154680"/>
+            <a:ext cx="4114800" cy="1188720"/>
           </a:xfrm>
           <a:prstGeom prst="rect">
             <a:avLst/>
@@ -5823,8 +6050,8 @@
         </p:nvSpPr>
         <p:spPr>
           <a:xfrm>
-            <a:off x="7315200" y="3264408"/>
-            <a:ext cx="1737360" cy="914400"/>
+            <a:off x="7680960" y="3264408"/>
+            <a:ext cx="1463040" cy="914400"/>
           </a:xfrm>
           <a:prstGeom prst="rect">
             <a:avLst/>
@@ -5848,7 +6075,7 @@
                   <a:srgbClr val="E07A1F"/>
                 </a:solidFill>
               </a:rPr>
-              <a:t>45</a:t>
+              <a:t>49%</a:t>
             </a:r>
           </a:p>
         </p:txBody>
@@ -5861,8 +6088,8 @@
         </p:nvSpPr>
         <p:spPr>
           <a:xfrm>
-            <a:off x="9052560" y="3264408"/>
-            <a:ext cx="2468880" cy="1005840"/>
+            <a:off x="9235440" y="3264408"/>
+            <a:ext cx="2286000" cy="1005840"/>
           </a:xfrm>
           <a:prstGeom prst="rect">
             <a:avLst/>
@@ -5886,7 +6113,7 @@
                   <a:srgbClr val="595959"/>
                 </a:solidFill>
               </a:rPr>
-              <a:t>ECs with fewer than 3 occupations at k = 10</a:t>
+              <a:t>of districts in homogeneous ECs at k = 10</a:t>
             </a:r>
           </a:p>
         </p:txBody>
@@ -5899,8 +6126,8 @@
         </p:nvSpPr>
         <p:spPr>
           <a:xfrm>
-            <a:off x="7132320" y="4526280"/>
-            <a:ext cx="4480560" cy="1188720"/>
+            <a:off x="7498079" y="4526280"/>
+            <a:ext cx="4114800" cy="1188720"/>
           </a:xfrm>
           <a:prstGeom prst="rect">
             <a:avLst/>
@@ -5943,8 +6170,8 @@
         </p:nvSpPr>
         <p:spPr>
           <a:xfrm>
-            <a:off x="7315200" y="4636008"/>
-            <a:ext cx="1737360" cy="914400"/>
+            <a:off x="7680960" y="4636008"/>
+            <a:ext cx="1463040" cy="914400"/>
           </a:xfrm>
           <a:prstGeom prst="rect">
             <a:avLst/>
@@ -5968,7 +6195,7 @@
                   <a:srgbClr val="E07A1F"/>
                 </a:solidFill>
               </a:rPr>
-              <a:t>k = 50</a:t>
+              <a:t>13</a:t>
             </a:r>
           </a:p>
         </p:txBody>
@@ -5981,8 +6208,8 @@
         </p:nvSpPr>
         <p:spPr>
           <a:xfrm>
-            <a:off x="9052560" y="4636008"/>
-            <a:ext cx="2468880" cy="1005840"/>
+            <a:off x="9235440" y="4636008"/>
+            <a:ext cx="2286000" cy="1005840"/>
           </a:xfrm>
           <a:prstGeom prst="rect">
             <a:avLst/>
@@ -6006,7 +6233,7 @@
                   <a:srgbClr val="595959"/>
                 </a:solidFill>
               </a:rPr>
-              <a:t>needed until every EC has 3 occupations</a:t>
+              <a:t>homogeneous ECs left even at k = 100</a:t>
             </a:r>
           </a:p>
         </p:txBody>
@@ -7772,7 +7999,7 @@
                 </a:solidFill>
                 <a:latin typeface="Consolas"/>
               </a:rPr>
-              <a:t>  --l=3 --ldiv=entropy --dataset=adult</a:t>
+              <a:t>  --l=2 --dataset=cahousing</a:t>
             </a:r>
           </a:p>
         </p:txBody>
@@ -7953,7 +8180,7 @@
         <p:spPr>
           <a:xfrm>
             <a:off x="548640" y="1371600"/>
-            <a:ext cx="5669280" cy="4754880"/>
+            <a:ext cx="5760720" cy="4754880"/>
           </a:xfrm>
           <a:prstGeom prst="rect">
             <a:avLst/>
@@ -7972,12 +8199,12 @@
               </a:spcAft>
             </a:pPr>
             <a:r>
-              <a:rPr sz="1700">
+              <a:rPr sz="1600">
                 <a:solidFill>
                   <a:srgbClr val="595959"/>
                 </a:solidFill>
               </a:rPr>
-              <a:t>•  Adult dataset, 30,162 records</a:t>
+              <a:t>•  cahousing, 20,640 districts</a:t>
             </a:r>
           </a:p>
           <a:p>
@@ -7987,12 +8214,12 @@
               </a:spcAft>
             </a:pPr>
             <a:r>
-              <a:rPr sz="1700">
+              <a:rPr sz="1600">
                 <a:solidFill>
                   <a:srgbClr val="595959"/>
                 </a:solidFill>
               </a:rPr>
-              <a:t>•  7 QIs: sex, age, race, marital-status, education, native-country, workclass</a:t>
+              <a:t>•  5 QIs: longitude, latitude, housing_median_age, median_income, median_house_value</a:t>
             </a:r>
           </a:p>
           <a:p>
@@ -8002,12 +8229,42 @@
               </a:spcAft>
             </a:pPr>
             <a:r>
-              <a:rPr sz="1700">
+              <a:rPr sz="1600">
                 <a:solidFill>
                   <a:srgbClr val="595959"/>
                 </a:solidFill>
               </a:rPr>
-              <a:t>•  SA: occupation (14 values, max. 13.4%)</a:t>
+              <a:t>•  SA: ocean_proximity, 3 values (4,953 / 9,136 / 6,551)</a:t>
+            </a:r>
+          </a:p>
+          <a:p>
+            <a:pPr lvl="1">
+              <a:spcAft>
+                <a:spcPts val="400"/>
+              </a:spcAft>
+            </a:pPr>
+            <a:r>
+              <a:rPr sz="1300">
+                <a:solidFill>
+                  <a:srgbClr val="595959"/>
+                </a:solidFill>
+              </a:rPr>
+              <a:t>–  same column is the classification target</a:t>
+            </a:r>
+          </a:p>
+          <a:p>
+            <a:pPr lvl="1">
+              <a:spcAft>
+                <a:spcPts val="400"/>
+              </a:spcAft>
+            </a:pPr>
+            <a:r>
+              <a:rPr sz="1300">
+                <a:solidFill>
+                  <a:srgbClr val="595959"/>
+                </a:solidFill>
+              </a:rPr>
+              <a:t>–  only l = 2, 3 possible, entropy l = 3 impossible</a:t>
             </a:r>
           </a:p>
           <a:p>
@@ -8017,12 +8274,12 @@
               </a:spcAft>
             </a:pPr>
             <a:r>
-              <a:rPr sz="1700">
+              <a:rPr sz="1600">
                 <a:solidFill>
                   <a:srgbClr val="595959"/>
                 </a:solidFill>
               </a:rPr>
-              <a:t>•  Metrics: NCP, DM, CAVG, #ECs, runtime</a:t>
+              <a:t>•  Metrics: NCP, DM, CAVG, #ECs</a:t>
             </a:r>
           </a:p>
           <a:p>
@@ -8032,12 +8289,12 @@
               </a:spcAft>
             </a:pPr>
             <a:r>
-              <a:rPr sz="1700">
+              <a:rPr sz="1600">
                 <a:solidFill>
                   <a:srgbClr val="595959"/>
                 </a:solidFill>
               </a:rPr>
-              <a:t>•  Privacy: homogeneous ECs, ECs with &lt; 3 values</a:t>
+              <a:t>•  Privacy: homogeneous ECs, majority share</a:t>
             </a:r>
           </a:p>
           <a:p>
@@ -8047,12 +8304,12 @@
               </a:spcAft>
             </a:pPr>
             <a:r>
-              <a:rPr sz="1700">
+              <a:rPr sz="1600">
                 <a:solidFill>
                   <a:srgbClr val="595959"/>
                 </a:solidFill>
               </a:rPr>
-              <a:t>•  KNN, SVM, RF on salary-class (80/20 split, weighted F1)</a:t>
+              <a:t>•  KNN, SVM, RF predict ocean_proximity (80/20, weighted F1)</a:t>
             </a:r>
           </a:p>
         </p:txBody>
@@ -8104,7 +8361,7 @@
                   <a:srgbClr val="FFFFFF"/>
                 </a:solidFill>
               </a:rPr>
-              <a:t>A</a:t>
+              <a:t>B</a:t>
             </a:r>
           </a:p>
         </p:txBody>
@@ -8156,7 +8413,7 @@
                   <a:srgbClr val="595959"/>
                 </a:solidFill>
               </a:rPr>
-              <a:t>k = 10, vary l</a:t>
+              <a:t>k = 2 ... 100</a:t>
             </a:r>
           </a:p>
           <a:p>
@@ -8167,7 +8424,7 @@
                   <a:srgbClr val="595959"/>
                 </a:solidFill>
               </a:rPr>
-              <a:t>(distinct 2-8, entropy 2-6, recursive 2-4)</a:t>
+              <a:t>TDG vs. distinct l = 2, l = 3, entropy l = 2</a:t>
             </a:r>
           </a:p>
         </p:txBody>
@@ -8219,7 +8476,7 @@
                   <a:srgbClr val="FFFFFF"/>
                 </a:solidFill>
               </a:rPr>
-              <a:t>B</a:t>
+              <a:t>C</a:t>
             </a:r>
           </a:p>
         </p:txBody>
@@ -8271,7 +8528,7 @@
                   <a:srgbClr val="595959"/>
                 </a:solidFill>
               </a:rPr>
-              <a:t>l = 3, vary k</a:t>
+              <a:t>k = 2, 10 and l = 2, 3</a:t>
             </a:r>
           </a:p>
           <a:p>
@@ -8282,7 +8539,7 @@
                   <a:srgbClr val="595959"/>
                 </a:solidFill>
               </a:rPr>
-              <a:t>(2, 3, 5, 10, 20, 50, 100)</a:t>
+              <a:t>reject vs. retry (10x) vs. repair</a:t>
             </a:r>
           </a:p>
         </p:txBody>
@@ -8334,7 +8591,7 @@
                   <a:srgbClr val="FFFFFF"/>
                 </a:solidFill>
               </a:rPr>
-              <a:t>C</a:t>
+              <a:t>R</a:t>
             </a:r>
           </a:p>
         </p:txBody>
@@ -8386,7 +8643,7 @@
                   <a:srgbClr val="595959"/>
                 </a:solidFill>
               </a:rPr>
-              <a:t>k = 10, l = 3 and 6</a:t>
+              <a:t>recursive (c = 2, l = 2, 3)</a:t>
             </a:r>
           </a:p>
           <a:p>
@@ -8397,7 +8654,7 @@
                   <a:srgbClr val="595959"/>
                 </a:solidFill>
               </a:rPr>
-              <a:t>split repair switched off</a:t>
+              <a:t>at k = 10</a:t>
             </a:r>
           </a:p>
         </p:txBody>
@@ -8453,7 +8710,7 @@
                   <a:srgbClr val="1F3A5F"/>
                 </a:solidFill>
               </a:rPr>
-              <a:t>Larger k is not enough</a:t>
+              <a:t>No homogeneous ECs, but distinct l is weak here</a:t>
             </a:r>
           </a:p>
         </p:txBody>
@@ -8571,7 +8828,7 @@
       </p:sp>
       <p:pic>
         <p:nvPicPr>
-          <p:cNvPr id="6" name="Picture 5" descr="adult_privacy_vs_k.png"/>
+          <p:cNvPr id="6" name="Picture 5" descr="cahousing_privacy_vs_k.png"/>
           <p:cNvPicPr>
             <a:picLocks noChangeAspect="1"/>
           </p:cNvPicPr>
@@ -8621,28 +8878,20 @@
               </a:spcAft>
             </a:pPr>
             <a:r>
+              <a:rPr sz="1600" b="1">
+                <a:solidFill>
+                  <a:srgbClr val="3C8D5A"/>
+                </a:solidFill>
+              </a:rPr>
+              <a:t>TDG + l: 0 homogeneous ECs in every run. </a:t>
+            </a:r>
+            <a:r>
               <a:rPr sz="1600" b="0">
                 <a:solidFill>
                   <a:srgbClr val="595959"/>
                 </a:solidFill>
               </a:rPr>
-              <a:t>Original TDG: 4,522 violating ECs at k = 2, still 1 at k = 20.  </a:t>
-            </a:r>
-            <a:r>
-              <a:rPr sz="1600" b="1">
-                <a:solidFill>
-                  <a:srgbClr val="3C8D5A"/>
-                </a:solidFill>
-              </a:rPr>
-              <a:t>TDG + l: 0 in every run. </a:t>
-            </a:r>
-            <a:r>
-              <a:rPr sz="1600" b="0">
-                <a:solidFill>
-                  <a:srgbClr val="595959"/>
-                </a:solidFill>
-              </a:rPr>
-              <a:t>3-diversity by raising k costs NCP 0.251 (k = 50) vs. 0.092 with k = 10, l = 3.</a:t>
+              <a:t>But majority guess still right for 87% (distinct l = 2), 81% (l = 3), 61% (entropy l = 2) at k = 10. Without QIs: 44%.</a:t>
             </a:r>
           </a:p>
         </p:txBody>
@@ -8698,7 +8947,7 @@
                   <a:srgbClr val="1F3A5F"/>
                 </a:solidFill>
               </a:rPr>
-              <a:t>Information loss for increasing l (k = 10)</a:t>
+              <a:t>Information loss</a:t>
             </a:r>
           </a:p>
         </p:txBody>
@@ -8816,7 +9065,7 @@
       </p:sp>
       <p:pic>
         <p:nvPicPr>
-          <p:cNvPr id="6" name="Picture 5" descr="adult_info_vs_l.png"/>
+          <p:cNvPr id="6" name="Picture 5" descr="cahousing_info_vs_k.png"/>
           <p:cNvPicPr>
             <a:picLocks noChangeAspect="1"/>
           </p:cNvPicPr>
@@ -8871,7 +9120,7 @@
                   <a:srgbClr val="595959"/>
                 </a:solidFill>
               </a:rPr>
-              <a:t>•  distinct l = 3: NCP 0.091 -&gt; 0.092, l = 8: 0.163; entropy is stricter (0.268 at l = 6)</a:t>
+              <a:t>•  distinct l = 2: NCP 0.16 -&gt; 0.32 (k = 2), 0.25 -&gt; 0.35 (k = 10); same NCP as plain TDG at k = 20 (0.32), which still leaks</a:t>
             </a:r>
           </a:p>
           <a:p>
@@ -8886,7 +9135,7 @@
                   <a:srgbClr val="595959"/>
                 </a:solidFill>
               </a:rPr>
-              <a:t>•  runtime in the same range for both (roughly 20-70 s per run), no large overhead from the repair</a:t>
+              <a:t>•  distinct l = 3 about 0.57, entropy l = 2 about 0.80, recursive (c = 2, l = 3): one single EC</a:t>
             </a:r>
           </a:p>
         </p:txBody>
@@ -8942,7 +9191,7 @@
                   <a:srgbClr val="1F3A5F"/>
                 </a:solidFill>
               </a:rPr>
-              <a:t>Why we repair instead of rejecting splits</a:t>
+              <a:t>Repairing splits beats rejecting or retrying</a:t>
             </a:r>
           </a:p>
         </p:txBody>
@@ -9060,7 +9309,7 @@
       </p:sp>
       <p:pic>
         <p:nvPicPr>
-          <p:cNvPr id="6" name="Picture 5" descr="adult_repair.png"/>
+          <p:cNvPr id="6" name="Picture 5" descr="cahousing_strategies.png"/>
           <p:cNvPicPr>
             <a:picLocks noChangeAspect="1"/>
           </p:cNvPicPr>
@@ -9075,7 +9324,7 @@
         <p:spPr>
           <a:xfrm>
             <a:off x="457200" y="1371600"/>
-            <a:ext cx="7315200" cy="2926080"/>
+            <a:ext cx="7498079" cy="2832608"/>
           </a:xfrm>
           <a:prstGeom prst="rect">
             <a:avLst/>
@@ -9090,8 +9339,8 @@
         </p:nvSpPr>
         <p:spPr>
           <a:xfrm>
-            <a:off x="8138160" y="1554480"/>
-            <a:ext cx="3566160" cy="3291840"/>
+            <a:off x="8229600" y="1554480"/>
+            <a:ext cx="3474720" cy="3566160"/>
           </a:xfrm>
           <a:prstGeom prst="rect">
             <a:avLst/>
@@ -9134,8 +9383,8 @@
         </p:nvSpPr>
         <p:spPr>
           <a:xfrm>
-            <a:off x="8321040" y="1691640"/>
-            <a:ext cx="3291840" cy="3108960"/>
+            <a:off x="8412480" y="1691640"/>
+            <a:ext cx="3200400" cy="3383280"/>
           </a:xfrm>
           <a:prstGeom prst="rect">
             <a:avLst/>
@@ -9156,10 +9405,10 @@
             <a:r>
               <a:rPr sz="1600" b="1">
                 <a:solidFill>
-                  <a:srgbClr val="C0392B"/>
-                </a:solidFill>
-              </a:rPr>
-              <a:t>Reject only</a:t>
+                  <a:srgbClr val="1F3A5F"/>
+                </a:solidFill>
+              </a:rPr>
+              <a:t>NCP at k = 2, l = 2</a:t>
             </a:r>
           </a:p>
           <a:p>
@@ -9174,7 +9423,7 @@
                   <a:srgbClr val="595959"/>
                 </a:solidFill>
               </a:rPr>
-              <a:t>NCP 0.450, 354 ECs (l = 3)</a:t>
+              <a:t>reject  0.469</a:t>
             </a:r>
           </a:p>
           <a:p>
@@ -9184,12 +9433,12 @@
               </a:spcAft>
             </a:pPr>
             <a:r>
-              <a:rPr sz="1600" b="1">
-                <a:solidFill>
-                  <a:srgbClr val="3C8D5A"/>
-                </a:solidFill>
-              </a:rPr>
-              <a:t>With repair</a:t>
+              <a:rPr sz="1600" b="0">
+                <a:solidFill>
+                  <a:srgbClr val="595959"/>
+                </a:solidFill>
+              </a:rPr>
+              <a:t>retry   0.421</a:t>
             </a:r>
           </a:p>
           <a:p>
@@ -9199,12 +9448,12 @@
               </a:spcAft>
             </a:pPr>
             <a:r>
-              <a:rPr sz="1600" b="0">
-                <a:solidFill>
-                  <a:srgbClr val="595959"/>
-                </a:solidFill>
-              </a:rPr>
-              <a:t>NCP 0.092, 1,758 ECs (l = 3)</a:t>
+              <a:rPr sz="1600" b="1">
+                <a:solidFill>
+                  <a:srgbClr val="3C8D5A"/>
+                </a:solidFill>
+              </a:rPr>
+              <a:t>repair  0.319</a:t>
             </a:r>
           </a:p>
           <a:p>
@@ -9229,12 +9478,57 @@
               </a:spcAft>
             </a:pPr>
             <a:r>
+              <a:rPr sz="1600" b="1">
+                <a:solidFill>
+                  <a:srgbClr val="1F3A5F"/>
+                </a:solidFill>
+              </a:rPr>
+              <a:t>NCP at k = 10, l = 3</a:t>
+            </a:r>
+          </a:p>
+          <a:p>
+            <a:pPr algn="l">
+              <a:spcAft>
+                <a:spcPts val="600"/>
+              </a:spcAft>
+            </a:pPr>
+            <a:r>
               <a:rPr sz="1600" b="0">
                 <a:solidFill>
                   <a:srgbClr val="595959"/>
                 </a:solidFill>
               </a:rPr>
-              <a:t>Moving a few records with missing occupations keeps the recursion going.</a:t>
+              <a:t>reject  0.714</a:t>
+            </a:r>
+          </a:p>
+          <a:p>
+            <a:pPr algn="l">
+              <a:spcAft>
+                <a:spcPts val="600"/>
+              </a:spcAft>
+            </a:pPr>
+            <a:r>
+              <a:rPr sz="1600" b="0">
+                <a:solidFill>
+                  <a:srgbClr val="595959"/>
+                </a:solidFill>
+              </a:rPr>
+              <a:t>retry   0.663</a:t>
+            </a:r>
+          </a:p>
+          <a:p>
+            <a:pPr algn="l">
+              <a:spcAft>
+                <a:spcPts val="600"/>
+              </a:spcAft>
+            </a:pPr>
+            <a:r>
+              <a:rPr sz="1600" b="1">
+                <a:solidFill>
+                  <a:srgbClr val="3C8D5A"/>
+                </a:solidFill>
+              </a:rPr>
+              <a:t>repair  0.566</a:t>
             </a:r>
           </a:p>
         </p:txBody>
@@ -9290,7 +9584,7 @@
                   <a:srgbClr val="1F3A5F"/>
                 </a:solidFill>
               </a:rPr>
-              <a:t>Classification performance barely changes</a:t>
+              <a:t>Classification: privacy and prediction collide</a:t>
             </a:r>
           </a:p>
         </p:txBody>
@@ -9408,7 +9702,7 @@
       </p:sp>
       <p:pic>
         <p:nvPicPr>
-          <p:cNvPr id="6" name="Picture 5" descr="adult_ml_vs_l.png"/>
+          <p:cNvPr id="6" name="Picture 5" descr="cahousing_ml_vs_k.png"/>
           <p:cNvPicPr>
             <a:picLocks noChangeAspect="1"/>
           </p:cNvPicPr>
@@ -9463,7 +9757,7 @@
                   <a:srgbClr val="595959"/>
                 </a:solidFill>
               </a:rPr>
-              <a:t>Weighted F1 (KNN / SVM / RF): </a:t>
+              <a:t>Weighted F1 (KNN / SVM / RF) at k = 10: </a:t>
             </a:r>
             <a:r>
               <a:rPr sz="1500" b="0">
@@ -9471,7 +9765,15 @@
                   <a:srgbClr val="595959"/>
                 </a:solidFill>
               </a:rPr>
-              <a:t>original 0.762 / 0.823 / 0.814, </a:t>
+              <a:t>original 0.54 / 0.86 / 0.95, TDG 0.58 / 0.81 / 0.86, </a:t>
+            </a:r>
+            <a:r>
+              <a:rPr sz="1500" b="1">
+                <a:solidFill>
+                  <a:srgbClr val="595959"/>
+                </a:solidFill>
+              </a:rPr>
+              <a:t>l = 2 0.56 / 0.80 / 0.85</a:t>
             </a:r>
             <a:r>
               <a:rPr sz="1500" b="0">
@@ -9479,15 +9781,7 @@
                   <a:srgbClr val="595959"/>
                 </a:solidFill>
               </a:rPr>
-              <a:t>TDG k = 10 0.762 / 0.818 / 0.811, </a:t>
-            </a:r>
-            <a:r>
-              <a:rPr sz="1500" b="1">
-                <a:solidFill>
-                  <a:srgbClr val="595959"/>
-                </a:solidFill>
-              </a:rPr>
-              <a:t>TDG + l = 3 0.763 / 0.816 / 0.811</a:t>
+              <a:t>, l = 3 0.53 / 0.74 / 0.81, entropy 0.47 / 0.59 / 0.65</a:t>
             </a:r>
           </a:p>
         </p:txBody>

</xml_diff>